<commit_message>
office: update AMAVIO final artifacts and coach package
</commit_message>
<xml_diff>
--- a/04_Final_Abgabe_v2_1/04_Decks/AMAVIO_Living_Employer_Decision_Deck_v5_2_FINAL.pptx
+++ b/04_Final_Abgabe_v2_1/04_Decks/AMAVIO_Living_Employer_Decision_Deck_v5_2_FINAL.pptx
@@ -553,7 +553,7 @@
           </a:p>
           <a:p xmlns:a="http://schemas.openxmlformats.org/drawingml/2006/main">
             <a:r>
-              <a:t>- Internal: AMAVIO Businessplan v1.7 und Produktarchitektur (Stand 28. Juli 2026).</a:t>
+              <a:t>- Internal: AMAVIO Businessplan v2.2 und Produktarchitektur (Stand 28. Juli 2026).</a:t>
             </a:r>
           </a:p>
           <a:p xmlns:a="http://schemas.openxmlformats.org/drawingml/2006/main">
@@ -638,7 +638,7 @@
           </a:p>
           <a:p xmlns:a="http://schemas.openxmlformats.org/drawingml/2006/main">
             <a:r>
-              <a:t>- Internal: AMAVIO Businessplan v1.7 und Produktarchitektur (Stand 28. Juli 2026).</a:t>
+              <a:t>- Internal: AMAVIO Businessplan v2.2 und Produktarchitektur (Stand 28. Juli 2026).</a:t>
             </a:r>
           </a:p>
           <a:p xmlns:a="http://schemas.openxmlformats.org/drawingml/2006/main">
@@ -723,7 +723,7 @@
           </a:p>
           <a:p xmlns:a="http://schemas.openxmlformats.org/drawingml/2006/main">
             <a:r>
-              <a:t>- Internal: AMAVIO Businessplan v1.7 und Produktarchitektur (Stand 28. Juli 2026).</a:t>
+              <a:t>- Internal: AMAVIO Businessplan v2.2 und Produktarchitektur (Stand 28. Juli 2026).</a:t>
             </a:r>
           </a:p>
           <a:p xmlns:a="http://schemas.openxmlformats.org/drawingml/2006/main">
@@ -808,7 +808,7 @@
           </a:p>
           <a:p xmlns:a="http://schemas.openxmlformats.org/drawingml/2006/main">
             <a:r>
-              <a:t>- Internal: AMAVIO Businessplan v1.7 und Produktarchitektur (Stand 28. Juli 2026).</a:t>
+              <a:t>- Internal: AMAVIO Businessplan v2.2 und Produktarchitektur (Stand 28. Juli 2026).</a:t>
             </a:r>
           </a:p>
           <a:p xmlns:a="http://schemas.openxmlformats.org/drawingml/2006/main">
@@ -893,7 +893,7 @@
           </a:p>
           <a:p xmlns:a="http://schemas.openxmlformats.org/drawingml/2006/main">
             <a:r>
-              <a:t>- Internal: AMAVIO Businessplan v1.7 und Produktarchitektur (Stand 28. Juli 2026).</a:t>
+              <a:t>- Internal: AMAVIO Businessplan v2.2 und Produktarchitektur (Stand 28. Juli 2026).</a:t>
             </a:r>
           </a:p>
           <a:p xmlns:a="http://schemas.openxmlformats.org/drawingml/2006/main">
@@ -978,7 +978,7 @@
           </a:p>
           <a:p xmlns:a="http://schemas.openxmlformats.org/drawingml/2006/main">
             <a:r>
-              <a:t>- Internal: AMAVIO Businessplan v1.7 und Produktarchitektur (Stand 28. Juli 2026).</a:t>
+              <a:t>- Internal: AMAVIO Businessplan v2.2 und Produktarchitektur (Stand 28. Juli 2026).</a:t>
             </a:r>
           </a:p>
           <a:p xmlns:a="http://schemas.openxmlformats.org/drawingml/2006/main">
@@ -1063,7 +1063,7 @@
           </a:p>
           <a:p xmlns:a="http://schemas.openxmlformats.org/drawingml/2006/main">
             <a:r>
-              <a:t>- Internal: AMAVIO Businessplan v1.7 und Produktarchitektur (Stand 28. Juli 2026).</a:t>
+              <a:t>- Internal: AMAVIO Businessplan v2.2 und Produktarchitektur (Stand 28. Juli 2026).</a:t>
             </a:r>
           </a:p>
           <a:p xmlns:a="http://schemas.openxmlformats.org/drawingml/2006/main">
@@ -1148,7 +1148,7 @@
           </a:p>
           <a:p xmlns:a="http://schemas.openxmlformats.org/drawingml/2006/main">
             <a:r>
-              <a:t>- Internal: AMAVIO Businessplan v1.7 und Produktarchitektur (Stand 28. Juli 2026).</a:t>
+              <a:t>- Internal: AMAVIO Businessplan v2.2 und Produktarchitektur (Stand 28. Juli 2026).</a:t>
             </a:r>
           </a:p>
           <a:p xmlns:a="http://schemas.openxmlformats.org/drawingml/2006/main">
@@ -1233,7 +1233,7 @@
           </a:p>
           <a:p xmlns:a="http://schemas.openxmlformats.org/drawingml/2006/main">
             <a:r>
-              <a:t>- Internal: AMAVIO Businessplan v1.7 und Produktarchitektur (Stand 28. Juli 2026).</a:t>
+              <a:t>- Internal: AMAVIO Businessplan v2.2 und Produktarchitektur (Stand 28. Juli 2026).</a:t>
             </a:r>
           </a:p>
           <a:p xmlns:a="http://schemas.openxmlformats.org/drawingml/2006/main">
@@ -1318,7 +1318,7 @@
           </a:p>
           <a:p xmlns:a="http://schemas.openxmlformats.org/drawingml/2006/main">
             <a:r>
-              <a:t>- Internal: AMAVIO Businessplan v1.7 und Produktarchitektur (Stand 28. Juli 2026).</a:t>
+              <a:t>- Internal: AMAVIO Businessplan v2.2 und Produktarchitektur (Stand 28. Juli 2026).</a:t>
             </a:r>
           </a:p>
           <a:p xmlns:a="http://schemas.openxmlformats.org/drawingml/2006/main">
@@ -1403,7 +1403,7 @@
           </a:p>
           <a:p xmlns:a="http://schemas.openxmlformats.org/drawingml/2006/main">
             <a:r>
-              <a:t>- Internal: AMAVIO Businessplan v1.7 und Produktarchitektur (Stand 28. Juli 2026).</a:t>
+              <a:t>- Internal: AMAVIO Businessplan v2.2 und Produktarchitektur (Stand 28. Juli 2026).</a:t>
             </a:r>
           </a:p>
           <a:p xmlns:a="http://schemas.openxmlformats.org/drawingml/2006/main">
@@ -1488,7 +1488,7 @@
           </a:p>
           <a:p xmlns:a="http://schemas.openxmlformats.org/drawingml/2006/main">
             <a:r>
-              <a:t>- Internal: AMAVIO Businessplan v1.7 und Produktarchitektur (Stand 28. Juli 2026).</a:t>
+              <a:t>- Internal: AMAVIO Businessplan v2.2 und Produktarchitektur (Stand 28. Juli 2026).</a:t>
             </a:r>
           </a:p>
           <a:p xmlns:a="http://schemas.openxmlformats.org/drawingml/2006/main">

</xml_diff>